<commit_message>
Revisão geral pós Sprint 1.
</commit_message>
<xml_diff>
--- a/artefatos/gerente_projetos/sprint_review_01.pptx
+++ b/artefatos/gerente_projetos/sprint_review_01.pptx
@@ -258,7 +258,7 @@
                 <a:tab pos="0" algn="l"/>
               </a:tabLst>
             </a:pPr>
-            <a:fld id="{B0BDED26-06BF-42E2-8B2E-E92B64C9D8AF}" type="slidenum">
+            <a:fld id="{2736388D-2256-4434-A1AE-B93CAC257D1F}" type="slidenum">
               <a:rPr lang="en-US" sz="1200" b="0" u="none" strike="noStrike">
                 <a:solidFill>
                   <a:schemeClr val="dk1">
@@ -1447,7 +1447,7 @@
                 <a:tab pos="0" algn="l"/>
               </a:tabLst>
             </a:pPr>
-            <a:fld id="{A2C9F0B1-83B9-409B-B022-97BA6E506C5E}" type="slidenum">
+            <a:fld id="{3E690754-2F94-44AD-9560-2A4F81D018EC}" type="slidenum">
               <a:rPr lang="en-US" sz="1200" b="0" u="none" strike="noStrike">
                 <a:solidFill>
                   <a:schemeClr val="dk1">
@@ -1796,7 +1796,7 @@
                 <a:tab pos="0" algn="l"/>
               </a:tabLst>
             </a:pPr>
-            <a:fld id="{5347CD37-F3C5-4F28-A3EA-0E2FEAEA15B6}" type="slidenum">
+            <a:fld id="{A333585C-EED6-4D01-88B9-C3E6CACF7FC4}" type="slidenum">
               <a:rPr lang="en-US" sz="1200" b="0" u="none" strike="noStrike">
                 <a:solidFill>
                   <a:schemeClr val="dk1">
@@ -2535,7 +2535,7 @@
                 <a:tab pos="0" algn="l"/>
               </a:tabLst>
             </a:pPr>
-            <a:fld id="{CDF0F1BA-E6C7-4D26-8916-50836FADC91E}" type="slidenum">
+            <a:fld id="{784D093B-67A7-454E-BD2D-AF6F6C88C97A}" type="slidenum">
               <a:rPr lang="en-US" sz="1200" b="0" u="none" strike="noStrike">
                 <a:solidFill>
                   <a:schemeClr val="dk1">
@@ -3438,7 +3438,7 @@
                 <a:tab pos="0" algn="l"/>
               </a:tabLst>
             </a:pPr>
-            <a:fld id="{1F7F8199-37AD-4D08-9645-81DFA9D4C41A}" type="slidenum">
+            <a:fld id="{69D54B98-2025-490A-940B-23CB46943544}" type="slidenum">
               <a:rPr lang="en-US" sz="1200" b="0" u="none" strike="noStrike">
                 <a:solidFill>
                   <a:schemeClr val="dk1">
@@ -3787,7 +3787,7 @@
                 <a:tab pos="0" algn="l"/>
               </a:tabLst>
             </a:pPr>
-            <a:fld id="{D237881B-0DC4-4443-BF85-90CDA4936D90}" type="slidenum">
+            <a:fld id="{02886C30-AC7A-4861-9C8F-CE063BAB6A57}" type="slidenum">
               <a:rPr lang="en-US" sz="1200" b="0" u="none" strike="noStrike">
                 <a:solidFill>
                   <a:schemeClr val="dk1">
@@ -4870,7 +4870,7 @@
                 <a:tab pos="0" algn="l"/>
               </a:tabLst>
             </a:pPr>
-            <a:fld id="{7D63BEFA-7600-46EB-A34E-3E19458548E6}" type="slidenum">
+            <a:fld id="{7E4D4EE9-FCFD-46A9-94FF-36066267400F}" type="slidenum">
               <a:rPr lang="en-US" sz="1200" b="0" u="none" strike="noStrike">
                 <a:solidFill>
                   <a:schemeClr val="dk1">
@@ -5525,7 +5525,7 @@
                 <a:tab pos="0" algn="l"/>
               </a:tabLst>
             </a:pPr>
-            <a:fld id="{81C28DFF-D385-4B5D-B50B-FC77A77F52F4}" type="slidenum">
+            <a:fld id="{A2C50934-CD3C-484A-A3F6-95F4BD97D105}" type="slidenum">
               <a:rPr lang="en-US" sz="1200" b="0" u="none" strike="noStrike">
                 <a:solidFill>
                   <a:schemeClr val="dk1">
@@ -6180,7 +6180,7 @@
                 <a:tab pos="0" algn="l"/>
               </a:tabLst>
             </a:pPr>
-            <a:fld id="{BD7BD86C-136D-437B-A823-FAB5D00C927E}" type="slidenum">
+            <a:fld id="{808CA58D-BC72-4D07-85E4-525AEA696D04}" type="slidenum">
               <a:rPr lang="en-US" sz="1200" b="0" u="none" strike="noStrike">
                 <a:solidFill>
                   <a:schemeClr val="dk1">
@@ -6619,7 +6619,7 @@
                 <a:tab pos="0" algn="l"/>
               </a:tabLst>
             </a:pPr>
-            <a:fld id="{3CA156AA-30F7-411D-8A5C-68CA6647B380}" type="slidenum">
+            <a:fld id="{D1558944-3F09-4148-A8F4-FB43ED65B0E3}" type="slidenum">
               <a:rPr lang="en-US" sz="1200" b="0" u="none" strike="noStrike">
                 <a:solidFill>
                   <a:schemeClr val="dk1">
@@ -7580,7 +7580,7 @@
                 <a:tab pos="0" algn="l"/>
               </a:tabLst>
             </a:pPr>
-            <a:fld id="{964F1DE8-3EC6-454E-8BF4-CB46052B4A4A}" type="slidenum">
+            <a:fld id="{0B051F80-A7BE-4975-94BF-333D4A2FF023}" type="slidenum">
               <a:rPr lang="en-US" sz="1200" b="0" u="none" strike="noStrike">
                 <a:solidFill>
                   <a:schemeClr val="dk1">
@@ -8705,7 +8705,7 @@
               </a:tabLst>
             </a:pPr>
             <a:r>
-              <a:rPr lang="en-US" sz="2800" b="0" u="none" strike="noStrike">
+              <a:rPr lang="en-US" sz="2600" b="0" u="none" strike="noStrike">
                 <a:solidFill>
                   <a:schemeClr val="dk1"/>
                 </a:solidFill>
@@ -8715,7 +8715,7 @@
               </a:rPr>
               <a:t>Colocar para rodar o back e o front</a:t>
             </a:r>
-            <a:endParaRPr lang="en-US" sz="2800" b="0" u="none" strike="noStrike">
+            <a:endParaRPr lang="en-US" sz="2600" b="0" u="none" strike="noStrike">
               <a:solidFill>
                 <a:schemeClr val="dk1"/>
               </a:solidFill>
@@ -8742,7 +8742,7 @@
               </a:tabLst>
             </a:pPr>
             <a:r>
-              <a:rPr lang="en-US" sz="2800" b="0" u="none" strike="noStrike">
+              <a:rPr lang="en-US" sz="2600" b="0" u="none" strike="noStrike">
                 <a:solidFill>
                   <a:schemeClr val="dk1"/>
                 </a:solidFill>
@@ -8752,7 +8752,7 @@
               </a:rPr>
               <a:t>Iniciar uma nova conversa</a:t>
             </a:r>
-            <a:endParaRPr lang="en-US" sz="2800" b="0" u="none" strike="noStrike">
+            <a:endParaRPr lang="en-US" sz="2600" b="0" u="none" strike="noStrike">
               <a:solidFill>
                 <a:schemeClr val="dk1"/>
               </a:solidFill>
@@ -8779,7 +8779,7 @@
               </a:tabLst>
             </a:pPr>
             <a:r>
-              <a:rPr lang="en-US" sz="2800" b="0" u="none" strike="noStrike">
+              <a:rPr lang="en-US" sz="2600" b="0" u="none" strike="noStrike">
                 <a:solidFill>
                   <a:schemeClr val="dk1"/>
                 </a:solidFill>
@@ -8789,7 +8789,7 @@
               </a:rPr>
               <a:t>Fornecer um nome e um CNPJ</a:t>
             </a:r>
-            <a:endParaRPr lang="en-US" sz="2800" b="0" u="none" strike="noStrike">
+            <a:endParaRPr lang="en-US" sz="2600" b="0" u="none" strike="noStrike">
               <a:solidFill>
                 <a:schemeClr val="dk1"/>
               </a:solidFill>
@@ -8816,7 +8816,7 @@
               </a:tabLst>
             </a:pPr>
             <a:r>
-              <a:rPr lang="en-US" sz="2800" b="0" u="none" strike="noStrike">
+              <a:rPr lang="en-US" sz="2600" b="0" u="none" strike="noStrike">
                 <a:solidFill>
                   <a:schemeClr val="dk1"/>
                 </a:solidFill>
@@ -8826,7 +8826,7 @@
               </a:rPr>
               <a:t>Mostrar</a:t>
             </a:r>
-            <a:endParaRPr lang="en-US" sz="2800" b="0" u="none" strike="noStrike">
+            <a:endParaRPr lang="en-US" sz="2600" b="0" u="none" strike="noStrike">
               <a:solidFill>
                 <a:schemeClr val="dk1"/>
               </a:solidFill>
@@ -8848,7 +8848,7 @@
               <a:buChar char=""/>
             </a:pPr>
             <a:r>
-              <a:rPr lang="en-US" sz="2800" b="0" u="none" strike="noStrike">
+              <a:rPr lang="en-US" sz="2600" b="0" u="none" strike="noStrike">
                 <a:solidFill>
                   <a:schemeClr val="dk1"/>
                 </a:solidFill>
@@ -8858,7 +8858,7 @@
               </a:rPr>
               <a:t>Empresa identificada</a:t>
             </a:r>
-            <a:endParaRPr lang="en-US" sz="2800" b="0" u="none" strike="noStrike">
+            <a:endParaRPr lang="en-US" sz="2600" b="0" u="none" strike="noStrike">
               <a:solidFill>
                 <a:schemeClr val="dk1"/>
               </a:solidFill>
@@ -8880,7 +8880,7 @@
               <a:buChar char=""/>
             </a:pPr>
             <a:r>
-              <a:rPr lang="en-US" sz="2800" b="0" u="none" strike="noStrike">
+              <a:rPr lang="en-US" sz="2600" b="0" u="none" strike="noStrike">
                 <a:solidFill>
                   <a:schemeClr val="dk1"/>
                 </a:solidFill>
@@ -8890,7 +8890,7 @@
               </a:rPr>
               <a:t>Nome do contato</a:t>
             </a:r>
-            <a:endParaRPr lang="en-US" sz="2800" b="0" u="none" strike="noStrike">
+            <a:endParaRPr lang="en-US" sz="2600" b="0" u="none" strike="noStrike">
               <a:solidFill>
                 <a:schemeClr val="dk1"/>
               </a:solidFill>
@@ -8912,7 +8912,7 @@
               <a:buChar char=""/>
             </a:pPr>
             <a:r>
-              <a:rPr lang="en-US" sz="2800" b="0" u="none" strike="noStrike">
+              <a:rPr lang="en-US" sz="2600" b="0" u="none" strike="noStrike">
                 <a:solidFill>
                   <a:schemeClr val="dk1"/>
                 </a:solidFill>
@@ -8922,7 +8922,7 @@
               </a:rPr>
               <a:t>Informação do processamento</a:t>
             </a:r>
-            <a:endParaRPr lang="en-US" sz="2800" b="0" u="none" strike="noStrike">
+            <a:endParaRPr lang="en-US" sz="2600" b="0" u="none" strike="noStrike">
               <a:solidFill>
                 <a:schemeClr val="dk1"/>
               </a:solidFill>
@@ -8943,17 +8943,48 @@
               <a:buChar char="•"/>
             </a:pPr>
             <a:r>
-              <a:rPr lang="en-US" sz="2800" b="0" u="none" strike="noStrike">
-                <a:solidFill>
-                  <a:schemeClr val="dk1"/>
-                </a:solidFill>
-                <a:effectLst/>
-                <a:uFillTx/>
-                <a:latin typeface="Calibri"/>
-              </a:rPr>
-              <a:t>Selecionar o 19991931173 e mostrar o report de problema </a:t>
-            </a:r>
-            <a:endParaRPr lang="en-US" sz="2800" b="0" u="none" strike="noStrike">
+              <a:rPr lang="en-US" sz="2600" b="0" u="none" strike="noStrike">
+                <a:solidFill>
+                  <a:schemeClr val="dk1"/>
+                </a:solidFill>
+                <a:effectLst/>
+                <a:uFillTx/>
+                <a:latin typeface="Calibri"/>
+              </a:rPr>
+              <a:t>Selecionar o 19991931173 e mostrar o report de problema</a:t>
+            </a:r>
+            <a:endParaRPr lang="en-US" sz="2600" b="0" u="none" strike="noStrike">
+              <a:solidFill>
+                <a:schemeClr val="dk1"/>
+              </a:solidFill>
+              <a:effectLst/>
+              <a:uFillTx/>
+              <a:latin typeface="Calibri"/>
+            </a:endParaRPr>
+          </a:p>
+          <a:p>
+            <a:pPr marL="343080" indent="-343080" algn="l" defTabSz="457200">
+              <a:spcBef>
+                <a:spcPts val="641"/>
+              </a:spcBef>
+              <a:buClr>
+                <a:srgbClr val="000000"/>
+              </a:buClr>
+              <a:buFont typeface="Arial"/>
+              <a:buChar char="•"/>
+            </a:pPr>
+            <a:r>
+              <a:rPr lang="en-US" sz="2600" b="0" u="none" strike="noStrike">
+                <a:solidFill>
+                  <a:schemeClr val="dk1"/>
+                </a:solidFill>
+                <a:effectLst/>
+                <a:uFillTx/>
+                <a:latin typeface="Calibri"/>
+              </a:rPr>
+              <a:t>Mostrar aba “Triagem de Reports”</a:t>
+            </a:r>
+            <a:endParaRPr lang="en-US" sz="2600" b="0" u="none" strike="noStrike">
               <a:solidFill>
                 <a:schemeClr val="dk1"/>
               </a:solidFill>
@@ -9285,43 +9316,6 @@
                 <a:latin typeface="Calibri"/>
               </a:rPr>
               <a:t>Melhorar fluxo de correção de problemas - Ações a partir de reports de triagem</a:t>
-            </a:r>
-            <a:endParaRPr lang="en-US" sz="2600" b="0" u="none" strike="noStrike">
-              <a:solidFill>
-                <a:schemeClr val="dk1"/>
-              </a:solidFill>
-              <a:effectLst/>
-              <a:uFillTx/>
-              <a:latin typeface="Calibri"/>
-            </a:endParaRPr>
-          </a:p>
-          <a:p>
-            <a:pPr marL="343080" indent="-343080" algn="l" defTabSz="457200">
-              <a:lnSpc>
-                <a:spcPct val="100000"/>
-              </a:lnSpc>
-              <a:spcBef>
-                <a:spcPts val="641"/>
-              </a:spcBef>
-              <a:buClr>
-                <a:srgbClr val="000000"/>
-              </a:buClr>
-              <a:buFont typeface="Arial"/>
-              <a:buChar char="•"/>
-              <a:tabLst>
-                <a:tab pos="0" algn="l"/>
-              </a:tabLst>
-            </a:pPr>
-            <a:r>
-              <a:rPr lang="en-US" sz="2600" b="0" u="none" strike="noStrike">
-                <a:solidFill>
-                  <a:schemeClr val="dk1"/>
-                </a:solidFill>
-                <a:effectLst/>
-                <a:uFillTx/>
-                <a:latin typeface="Calibri"/>
-              </a:rPr>
-              <a:t>Página cockpit de acompanhamento de conversas - Visualização operacional</a:t>
             </a:r>
             <a:endParaRPr lang="en-US" sz="2600" b="0" u="none" strike="noStrike">
               <a:solidFill>

</xml_diff>